<commit_message>
docs(presentacion): archivo de la presentacion con las primeras diapositivas recortadas
Co-Authored-By: Claude Opus 5 (1M context) <noreply@anthropic.com>
</commit_message>
<xml_diff>
--- a/presentacion/tesis_emps_2026_v3.pptx
+++ b/presentacion/tesis_emps_2026_v3.pptx
@@ -1023,7 +1023,7 @@
           <a:lstStyle/>
           <a:p>
             <a:r>
-              <a:t>Aquí está lo nuevo de este mes, y sale de una investigación de precios que hice el nueve de septiembre con las páginas oficiales. Las herramientas se cobran por persona, no por equipo, porque así las venden: un asiento por cada persona técnica. Y como en la vida real cada quien trae su plan, hay tres niveles: básico, típico y máximo. Por ejemplo, para casi todo con inteligencia artificial, cien, doscientos cincuenta o cuatrocientos dólares por persona al mes. Se elige por proyecto, y además cada persona puede traer su propio plan.</a:t>
+              <a:t>Esta parte sale de una investigación de precios que hice el nueve de septiembre con las páginas oficiales de cada herramienta. Las herramientas se cobran por persona, no por equipo, porque así las venden: un asiento por cada persona técnica. Y como en la vida real cada quien trae su plan, hay tres niveles: básico, típico y máximo. Por ejemplo, para casi todo con inteligencia artificial, cien, doscientos cincuenta o cuatrocientos dólares por persona al mes. Se elige por proyecto, y además cada persona puede traer su propio plan.</a:t>
             </a:r>
           </a:p>
         </p:txBody>
@@ -2073,7 +2073,7 @@
           <a:lstStyle/>
           <a:p>
             <a:r>
-              <a:t>Cuando empecé la tesis, la pregunta era cuántas horas de programación lleva un sistema. Pero en este año y medio la forma de hacer software cambió mes con mes. En 2024, seis de cada diez desarrolladores usaban inteligencia artificial. En 2025, casi ocho. En 2026, más de ocho. Y lo nuevo no es que la computadora complete una línea, sino que un agente hace la tarea completa: nueve de cada diez profesionales ya usan agentes cada semana. GitHub dice que cuarenta y uno por ciento del código nuevo se genera con inteligencia artificial. Esto ya es un mercado de diez mil millones de dólares. Para la tesis significa algo muy concreto: si mi modelo asumía que las horas de programación eran el centro del costo, ese modelo nació viejo. Había que cambiarlo.</a:t>
+              <a:t>La pregunta de siempre en esta área es cuántas horas de programación lleva un sistema. El asunto es que la forma de hacer software está cambiando mes con mes. En 2024, seis de cada diez desarrolladores usaban inteligencia artificial. En 2025, casi ocho. En 2026, más de ocho. Y lo nuevo no es que la computadora complete una línea, sino que un agente hace la tarea completa: nueve de cada diez profesionales ya usan agentes cada semana. GitHub dice que cuarenta y uno por ciento del código nuevo se genera con inteligencia artificial. Esto ya es un mercado de diez mil millones de dólares. Para la tesis significa algo muy concreto: un modelo que asuma que las horas de programación son el centro del costo se queda corto. Por eso desde el diseño el sistema calcula con cinco formas de hacerlo, no con una sola.</a:t>
             </a:r>
           </a:p>
         </p:txBody>
@@ -2703,7 +2703,7 @@
           <a:lstStyle/>
           <a:p>
             <a:r>
-              <a:t>Resumo lo que dicen los datos. Primero: con las variables que se conocen al inicio del proyecto, un modelo estadístico que se llama bosque aleatorio explicó ochenta y uno por ciento de la variación del esfuerzo en los proyectos completos. El promedio, que es lo que se usa normalmente, explicó cero. Eso respalda la tercera hipótesis. Segundo: el experto ordena pero no dimensiona; eso respalda la primera. Tercero: la segunda hipótesis no se confirmó: buscar cambios por palabras en el texto de la tarea no distingue nada. Y eso cambió el sistema: los cambios se capturan de forma estructurada, con su tipo y su fase, no se adivinan. Todo esto lo verificó un programa aparte, veintiséis de veintiséis comprobaciones.</a:t>
+              <a:t>Resumo lo que dicen los datos. Primero: con las variables que se conocen al inicio del proyecto, un modelo estadístico que se llama bosque aleatorio explicó ochenta y uno por ciento de la variación del esfuerzo en los proyectos completos. El promedio, que es lo que se usa normalmente, explicó cero. Eso respalda la tercera hipótesis. Segundo: el experto ordena pero no dimensiona; eso respalda la primera. Tercero: la segunda hipótesis no se confirmó: buscar cambios por palabras en el texto de la tarea no distingue nada. Por eso el sistema captura los cambios de forma estructurada, con su tipo y su fase, en lugar de adivinarlos del texto. Todo esto lo verificó un programa aparte, veintiséis de veintiséis comprobaciones.</a:t>
             </a:r>
           </a:p>
         </p:txBody>
@@ -8503,7 +8503,7 @@
                 </a:solidFill>
                 <a:latin typeface="Arial"/>
               </a:rPr>
-              <a:t>•  Un Ayuntamiento recibe cotizaciones que no puede comparar y no sabe si el proveedor que cotizó barato va a poder terminar.</a:t>
+              <a:t>•  El Ayuntamiento recibe cotizaciones que no puede comparar.</a:t>
             </a:r>
           </a:p>
           <a:p>
@@ -8522,7 +8522,7 @@
                 </a:solidFill>
                 <a:latin typeface="Arial"/>
               </a:rPr>
-              <a:t>•  Un proveedor sabe programar, pero no sabe cuánto cobrar: si cobra caro pierde el contrato; si cobra barato se queda sin dinero a la mitad.</a:t>
+              <a:t>•  El proveedor no sabe cuánto cobrar: caro pierde el contrato, barato se queda a media obra.</a:t>
             </a:r>
           </a:p>
           <a:p>
@@ -8541,7 +8541,7 @@
                 </a:solidFill>
                 <a:latin typeface="Arial"/>
               </a:rPr>
-              <a:t>•  En 120 proyectos reales de 42 organizaciones, 8 de cada 10 costaron más esfuerzo del estimado, con una desviación mediana de 58.6 % (dataset SEERA).</a:t>
+              <a:t>•  8 de cada 10 proyectos costaron más de lo estimado (120 proyectos, SEERA).</a:t>
             </a:r>
           </a:p>
           <a:p>
@@ -8560,7 +8560,7 @@
                 </a:solidFill>
                 <a:latin typeface="Arial"/>
               </a:rPr>
-              <a:t>•  De 4,329 tareas estimadas por expertos, solo 4 de cada 10 cayeron dentro de más o menos 15 % del valor real (dataset JOSSE, tareas de Jira de código abierto).</a:t>
+              <a:t>•  Solo 4 de cada 10 estimaciones de expertos quedaron cerca de lo real (4,329 tareas, JOSSE).</a:t>
             </a:r>
           </a:p>
         </p:txBody>
@@ -11511,7 +11511,7 @@
                 </a:solidFill>
                 <a:latin typeface="Arial"/>
               </a:rPr>
-              <a:t>Lo que cambió mientras hacía la tesis</a:t>
+              <a:t>Hoy el software no se hace como antes</a:t>
             </a:r>
           </a:p>
         </p:txBody>
@@ -11553,7 +11553,7 @@
                 </a:solidFill>
                 <a:latin typeface="Arial"/>
               </a:rPr>
-              <a:t>•  Uso de inteligencia artificial para programar: 62 % de los desarrolladores en 2024, 78 % en 2025 y 84 % en 2026 (Stack Overflow, 49,000 respuestas en 2026).</a:t>
+              <a:t>•  84 % de los desarrolladores usa inteligencia artificial para programar (Stack Overflow, 2026).</a:t>
             </a:r>
           </a:p>
           <a:p>
@@ -11572,7 +11572,7 @@
                 </a:solidFill>
                 <a:latin typeface="Arial"/>
               </a:rPr>
-              <a:t>•  90 % ya usa agentes de código cada semana y 68 % todos los días (JetBrains, 15,000 profesionales, agosto de 2026).</a:t>
+              <a:t>•  90 % usa agentes de código cada semana (JetBrains, 2026).</a:t>
             </a:r>
           </a:p>
           <a:p>
@@ -11591,7 +11591,7 @@
                 </a:solidFill>
                 <a:latin typeface="Arial"/>
               </a:rPr>
-              <a:t>•  41 % del código nuevo se reporta como generado con inteligencia artificial (GitHub Octoverse, octubre de 2025).</a:t>
+              <a:t>•  41 % del código nuevo se genera con inteligencia artificial (GitHub, 2025).</a:t>
             </a:r>
           </a:p>
           <a:p>
@@ -11604,32 +11604,13 @@
               </a:spcAft>
             </a:pPr>
             <a:r>
-              <a:rPr sz="2200" b="0" i="0">
-                <a:solidFill>
-                  <a:srgbClr val="1A1A1A"/>
-                </a:solidFill>
-                <a:latin typeface="Arial"/>
-              </a:rPr>
-              <a:t>•  El mercado de agentes de código para empresas vale diez mil millones de dólares al año (Gartner, mayo de 2026).</a:t>
-            </a:r>
-          </a:p>
-          <a:p>
-            <a:pPr algn="l">
-              <a:lnSpc>
-                <a:spcPct val="120000"/>
-              </a:lnSpc>
-              <a:spcAft>
-                <a:spcPts val="1400"/>
-              </a:spcAft>
-            </a:pPr>
-            <a:r>
               <a:rPr sz="2200" b="1" i="0">
                 <a:solidFill>
                   <a:srgbClr val="1F3864"/>
                 </a:solidFill>
                 <a:latin typeface="Arial"/>
               </a:rPr>
-              <a:t>Un modelo de estimación que asume que las horas de programación son el centro del costo ya nació viejo.</a:t>
+              <a:t>Estimar solo horas de programación ya no alcanza. Por eso el sistema calcula con cinco formas de hacerlo.</a:t>
             </a:r>
           </a:p>
         </p:txBody>
@@ -12894,7 +12875,7 @@
                 </a:solidFill>
                 <a:latin typeface="Arial"/>
               </a:rPr>
-              <a:t>•  Desarrolladores experimentados, trabajando en su propio código con inteligencia artificial, tardaron 19 % más y creían haber sido 20 % más rápidos (METR, ensayo controlado, 2025).</a:t>
+              <a:t>•  Expertos en su propio código tardaron 19 % más y creían ir 20 % más rápido (METR, 2025).</a:t>
             </a:r>
           </a:p>
           <a:p>
@@ -12913,7 +12894,7 @@
                 </a:solidFill>
                 <a:latin typeface="Arial"/>
               </a:rPr>
-              <a:t>•  En 623 millones de cambios de código, la duplicación subió 81 % y la refactorización cayó 70 % (GitClear, enero de 2026).</a:t>
+              <a:t>•  Se copia 81 % más código y se limpia 70 % menos (GitClear, 623 millones de cambios).</a:t>
             </a:r>
           </a:p>
           <a:p>
@@ -12932,7 +12913,7 @@
                 </a:solidFill>
                 <a:latin typeface="Arial"/>
               </a:rPr>
-              <a:t>•  45 % del código generado por inteligencia artificial trae una falla de seguridad, y esa cifra lleva dos años sin mejorar (Veracode, marzo de 2026).</a:t>
+              <a:t>•  45 % del código generado trae una falla de seguridad (Veracode, 2026).</a:t>
             </a:r>
           </a:p>
           <a:p>
@@ -12945,32 +12926,13 @@
               </a:spcAft>
             </a:pPr>
             <a:r>
-              <a:rPr sz="2200" b="0" i="0">
-                <a:solidFill>
-                  <a:srgbClr val="1A1A1A"/>
-                </a:solidFill>
-                <a:latin typeface="Arial"/>
-              </a:rPr>
-              <a:t>•  Los cambios hechos con inteligencia artificial se aceptan en 30 días solo 33 % de las veces, contra 84 % sin ella (LinearB, 8.1 millones de cambios, 2026).</a:t>
-            </a:r>
-          </a:p>
-          <a:p>
-            <a:pPr algn="l">
-              <a:lnSpc>
-                <a:spcPct val="120000"/>
-              </a:lnSpc>
-              <a:spcAft>
-                <a:spcPts val="1400"/>
-              </a:spcAft>
-            </a:pPr>
-            <a:r>
               <a:rPr sz="2200" b="1" i="0">
                 <a:solidFill>
                   <a:srgbClr val="1F3864"/>
                 </a:solidFill>
                 <a:latin typeface="Arial"/>
               </a:rPr>
-              <a:t>La ganancia depende de la forma de hacerlo y de la pericia de quien usa la herramienta. Por eso el sistema las trata por separado.</a:t>
+              <a:t>La ganancia depende de la forma de hacerlo y de la pericia del equipo. El sistema las cobra por separado.</a:t>
             </a:r>
           </a:p>
         </p:txBody>
@@ -13158,7 +13120,7 @@
                 </a:solidFill>
                 <a:latin typeface="Arial"/>
               </a:rPr>
-              <a:t>•  Antes, el ajuste chico (que este texto no se ve bien, que este campo debe validar) era un ticket, una espera y a veces un cobro aparte. Hoy se resuelve en la misma sesión.</a:t>
+              <a:t>•  El ajuste chico antes era un ticket y una espera. Hoy se resuelve en la misma sesión.</a:t>
             </a:r>
           </a:p>
           <a:p>
@@ -13177,7 +13139,7 @@
                 </a:solidFill>
                 <a:latin typeface="Arial"/>
               </a:rPr>
-              <a:t>•  En 3,400 repositorios, adoptar inteligencia artificial subió 19 % los cambios terminados y ahorró de 2 a 4 horas por persona a la semana; el efecto fue mayor en los repositorios chicos (Atlassian, mayo de 2026).</a:t>
+              <a:t>•  Los cambios terminados suben 19 % y cada persona ahorra de 2 a 4 horas por semana (Atlassian, 3,400 repositorios).</a:t>
             </a:r>
           </a:p>
           <a:p>
@@ -13196,26 +13158,7 @@
                 </a:solidFill>
                 <a:latin typeface="Arial"/>
               </a:rPr>
-              <a:t>•  En una empresa con 802 desarrolladores, el rendimiento por persona llegó a 2.09 veces, aunque la carga de quien revisa se duplicó (arXiv, julio de 2026).</a:t>
-            </a:r>
-          </a:p>
-          <a:p>
-            <a:pPr algn="l">
-              <a:lnSpc>
-                <a:spcPct val="120000"/>
-              </a:lnSpc>
-              <a:spcAft>
-                <a:spcPts val="1400"/>
-              </a:spcAft>
-            </a:pPr>
-            <a:r>
-              <a:rPr sz="2000" b="0" i="0">
-                <a:solidFill>
-                  <a:srgbClr val="1A1A1A"/>
-                </a:solidFill>
-                <a:latin typeface="Arial"/>
-              </a:rPr>
-              <a:t>•  De 8,106 correcciones hechas por agentes, 65 % se aceptaron (arXiv, enero de 2026).</a:t>
+              <a:t>•  De 8,106 correcciones hechas por agentes, 65 % se aceptaron (arXiv, 2026).</a:t>
             </a:r>
           </a:p>
           <a:p>

</xml_diff>

<commit_message>
docs(presentacion): el escudo de la UAZ ya va en la portada
Se saca del articulo del propio alumno (word/media/image1.jpg) y se guarda como
presentacion/capturas/escudo_uaz.png. La portada lo coloca centrado y con su
proporcion; si el archivo faltara, se dibuja el recuadro como antes. Se retira
el recordatorio de pegarlo a mano.

Co-Authored-By: Claude Opus 5 (1M context) <noreply@anthropic.com>
</commit_message>
<xml_diff>
--- a/presentacion/tesis_emps_2026_v3.pptx
+++ b/presentacion/tesis_emps_2026_v3.pptx
@@ -5753,50 +5753,30 @@
           </a:p>
         </p:txBody>
       </p:sp>
-      <p:sp>
-        <p:nvSpPr>
-          <p:cNvPr id="3" name="Rectangle 2"/>
-          <p:cNvSpPr/>
-          <p:nvPr/>
-        </p:nvSpPr>
-        <p:spPr>
-          <a:xfrm>
-            <a:off x="5501487" y="640080"/>
-            <a:ext cx="1188720" cy="1188720"/>
-          </a:xfrm>
-          <a:prstGeom prst="rect">
-            <a:avLst/>
-          </a:prstGeom>
-          <a:noFill/>
-          <a:ln w="9525">
-            <a:solidFill>
-              <a:srgbClr val="BFBFBF"/>
-            </a:solidFill>
-          </a:ln>
-          <a:effectLst/>
-        </p:spPr>
-        <p:style>
-          <a:lnRef idx="1">
-            <a:schemeClr val="accent1"/>
-          </a:lnRef>
-          <a:fillRef idx="3">
-            <a:schemeClr val="accent1"/>
-          </a:fillRef>
-          <a:effectRef idx="2">
-            <a:schemeClr val="accent1"/>
-          </a:effectRef>
-          <a:fontRef idx="minor">
-            <a:schemeClr val="lt1"/>
-          </a:fontRef>
-        </p:style>
-        <p:txBody>
-          <a:bodyPr rtlCol="0" anchor="ctr"/>
-          <a:lstStyle/>
-          <a:p>
-            <a:pPr algn="ctr"/>
-          </a:p>
-        </p:txBody>
-      </p:sp>
+      <p:pic>
+        <p:nvPicPr>
+          <p:cNvPr id="3" name="Picture 2" descr="escudo_uaz.png"/>
+          <p:cNvPicPr>
+            <a:picLocks noChangeAspect="1"/>
+          </p:cNvPicPr>
+          <p:nvPr/>
+        </p:nvPicPr>
+        <p:blipFill>
+          <a:blip r:embed="rId2"/>
+          <a:stretch>
+            <a:fillRect/>
+          </a:stretch>
+        </p:blipFill>
+        <p:spPr>
+          <a:xfrm>
+            <a:off x="5440385" y="640080"/>
+            <a:ext cx="1310924" cy="1188720"/>
+          </a:xfrm>
+          <a:prstGeom prst="rect">
+            <a:avLst/>
+          </a:prstGeom>
+        </p:spPr>
+      </p:pic>
       <p:sp>
         <p:nvSpPr>
           <p:cNvPr id="4" name="TextBox 3"/>
@@ -5805,8 +5785,8 @@
         </p:nvSpPr>
         <p:spPr>
           <a:xfrm>
-            <a:off x="5501487" y="1051560"/>
-            <a:ext cx="1188720" cy="365760"/>
+            <a:off x="640080" y="1920240"/>
+            <a:ext cx="10911535" cy="822960"/>
           </a:xfrm>
           <a:prstGeom prst="rect">
             <a:avLst/>
@@ -5824,17 +5804,36 @@
                 <a:spcPct val="120000"/>
               </a:lnSpc>
               <a:spcAft>
+                <a:spcPts val="200"/>
+              </a:spcAft>
+            </a:pPr>
+            <a:r>
+              <a:rPr sz="2200" b="1" i="0">
+                <a:solidFill>
+                  <a:srgbClr val="1F3864"/>
+                </a:solidFill>
+                <a:latin typeface="Arial"/>
+              </a:rPr>
+              <a:t>Universidad Autónoma de Zacatecas</a:t>
+            </a:r>
+          </a:p>
+          <a:p>
+            <a:pPr algn="ctr">
+              <a:lnSpc>
+                <a:spcPct val="120000"/>
+              </a:lnSpc>
+              <a:spcAft>
                 <a:spcPts val="1000"/>
               </a:spcAft>
             </a:pPr>
             <a:r>
-              <a:rPr sz="1000" b="0" i="0">
-                <a:solidFill>
-                  <a:srgbClr val="595959"/>
-                </a:solidFill>
-                <a:latin typeface="Arial"/>
-              </a:rPr>
-              <a:t>Escudo UAZ</a:t>
+              <a:rPr sz="1600" b="0" i="0">
+                <a:solidFill>
+                  <a:srgbClr val="1A1A1A"/>
+                </a:solidFill>
+                <a:latin typeface="Arial"/>
+              </a:rPr>
+              <a:t>Ingeniería en Software. Seminario de Tesis, agosto a diciembre de 2026</a:t>
             </a:r>
           </a:p>
         </p:txBody>
@@ -5847,8 +5846,8 @@
         </p:nvSpPr>
         <p:spPr>
           <a:xfrm>
-            <a:off x="640080" y="1920240"/>
-            <a:ext cx="10911535" cy="822960"/>
+            <a:off x="640080" y="2880360"/>
+            <a:ext cx="10911535" cy="1828800"/>
           </a:xfrm>
           <a:prstGeom prst="rect">
             <a:avLst/>
@@ -5863,39 +5862,39 @@
           <a:p>
             <a:pPr algn="ctr">
               <a:lnSpc>
+                <a:spcPct val="110000"/>
+              </a:lnSpc>
+              <a:spcAft>
+                <a:spcPts val="800"/>
+              </a:spcAft>
+            </a:pPr>
+            <a:r>
+              <a:rPr sz="2800" b="1" i="0">
+                <a:solidFill>
+                  <a:srgbClr val="1F3864"/>
+                </a:solidFill>
+                <a:latin typeface="Arial"/>
+              </a:rPr>
+              <a:t>Estimación temprana de esfuerzo, tiempo y costo en proyectos de software para gobiernos municipales</a:t>
+            </a:r>
+          </a:p>
+          <a:p>
+            <a:pPr algn="ctr">
+              <a:lnSpc>
                 <a:spcPct val="120000"/>
               </a:lnSpc>
               <a:spcAft>
-                <a:spcPts val="200"/>
-              </a:spcAft>
-            </a:pPr>
-            <a:r>
-              <a:rPr sz="2200" b="1" i="0">
-                <a:solidFill>
-                  <a:srgbClr val="1F3864"/>
-                </a:solidFill>
-                <a:latin typeface="Arial"/>
-              </a:rPr>
-              <a:t>Universidad Autónoma de Zacatecas</a:t>
-            </a:r>
-          </a:p>
-          <a:p>
-            <a:pPr algn="ctr">
-              <a:lnSpc>
-                <a:spcPct val="120000"/>
-              </a:lnSpc>
-              <a:spcAft>
                 <a:spcPts val="1000"/>
               </a:spcAft>
             </a:pPr>
             <a:r>
-              <a:rPr sz="1600" b="0" i="0">
+              <a:rPr sz="1800" b="0" i="0">
                 <a:solidFill>
                   <a:srgbClr val="1A1A1A"/>
                 </a:solidFill>
                 <a:latin typeface="Arial"/>
               </a:rPr>
-              <a:t>Ingeniería en Software. Seminario de Tesis, agosto a diciembre de 2026</a:t>
+              <a:t>Propuesta metodológica para el control de cambios, con referencia a Fresnillo, Zacatecas</a:t>
             </a:r>
           </a:p>
         </p:txBody>
@@ -5908,8 +5907,8 @@
         </p:nvSpPr>
         <p:spPr>
           <a:xfrm>
-            <a:off x="640080" y="2880360"/>
-            <a:ext cx="10911535" cy="1828800"/>
+            <a:off x="640080" y="4892040"/>
+            <a:ext cx="10911535" cy="1554480"/>
           </a:xfrm>
           <a:prstGeom prst="rect">
             <a:avLst/>
@@ -5924,67 +5923,6 @@
           <a:p>
             <a:pPr algn="ctr">
               <a:lnSpc>
-                <a:spcPct val="110000"/>
-              </a:lnSpc>
-              <a:spcAft>
-                <a:spcPts val="800"/>
-              </a:spcAft>
-            </a:pPr>
-            <a:r>
-              <a:rPr sz="2800" b="1" i="0">
-                <a:solidFill>
-                  <a:srgbClr val="1F3864"/>
-                </a:solidFill>
-                <a:latin typeface="Arial"/>
-              </a:rPr>
-              <a:t>Estimación temprana de esfuerzo, tiempo y costo en proyectos de software para gobiernos municipales</a:t>
-            </a:r>
-          </a:p>
-          <a:p>
-            <a:pPr algn="ctr">
-              <a:lnSpc>
-                <a:spcPct val="120000"/>
-              </a:lnSpc>
-              <a:spcAft>
-                <a:spcPts val="1000"/>
-              </a:spcAft>
-            </a:pPr>
-            <a:r>
-              <a:rPr sz="1800" b="0" i="0">
-                <a:solidFill>
-                  <a:srgbClr val="1A1A1A"/>
-                </a:solidFill>
-                <a:latin typeface="Arial"/>
-              </a:rPr>
-              <a:t>Propuesta metodológica para el control de cambios, con referencia a Fresnillo, Zacatecas</a:t>
-            </a:r>
-          </a:p>
-        </p:txBody>
-      </p:sp>
-      <p:sp>
-        <p:nvSpPr>
-          <p:cNvPr id="7" name="TextBox 6"/>
-          <p:cNvSpPr txBox="1"/>
-          <p:nvPr/>
-        </p:nvSpPr>
-        <p:spPr>
-          <a:xfrm>
-            <a:off x="640080" y="4892040"/>
-            <a:ext cx="10911535" cy="1554480"/>
-          </a:xfrm>
-          <a:prstGeom prst="rect">
-            <a:avLst/>
-          </a:prstGeom>
-          <a:noFill/>
-        </p:spPr>
-        <p:txBody>
-          <a:bodyPr wrap="square" anchor="t" lIns="45720" rIns="45720" tIns="27432" bIns="27432">
-            <a:spAutoFit/>
-          </a:bodyPr>
-          <a:lstStyle/>
-          <a:p>
-            <a:pPr algn="ctr">
-              <a:lnSpc>
                 <a:spcPct val="120000"/>
               </a:lnSpc>
               <a:spcAft>
@@ -6062,14 +6000,14 @@
       </p:sp>
       <p:pic>
         <p:nvPicPr>
-          <p:cNvPr id="8" name="Picture 7" descr="logo_emps.png"/>
+          <p:cNvPr id="7" name="Picture 6" descr="logo_emps.png"/>
           <p:cNvPicPr>
             <a:picLocks noChangeAspect="1"/>
           </p:cNvPicPr>
           <p:nvPr/>
         </p:nvPicPr>
         <p:blipFill>
-          <a:blip r:embed="rId2"/>
+          <a:blip r:embed="rId3"/>
           <a:stretch>
             <a:fillRect/>
           </a:stretch>

</xml_diff>

<commit_message>
docs(presentacion): guion mas facil de leer, una frase por renglon y sin palabras tecnicas
Notas alineadas con las diapositivas recortadas; se explican correlacion y
pericia en la misma frase; glosario solo con lo que de verdad se dice; el Word
abre con como usarlo y cada frase va en su renglon para leer mientras se graba.

Co-Authored-By: Claude Fable 5.1 <noreply@anthropic.com>
</commit_message>
<xml_diff>
--- a/presentacion/tesis_emps_2026_v3.pptx
+++ b/presentacion/tesis_emps_2026_v3.pptx
@@ -1093,7 +1093,7 @@
           <a:lstStyle/>
           <a:p>
             <a:r>
-              <a:t>Y esto es lo que el sistema le enseña antes de calcular: con este equipo de cuatro personas técnicas, cuánto costarían las herramientas al mes en cada forma de hacerlo, y qué parte del ahorro se acredita según la pericia del equipo. La pericia se captura por persona, del uno al cinco. Los ahorros publicados están calibrados para quien usa la herramienta a diario y sabe darle instrucciones. A quien nunca la ha usado solo se le acredita treinta y cinco por ciento, porque un modelo muy potente en manos de quien no sabe pedirle las cosas no ahorra tiempo. Eso es exactamente lo que midió el estudio de METR.</a:t>
+              <a:t>Y esto es lo que el sistema le enseña antes de calcular: con este equipo de cuatro personas técnicas, cuánto costarían las herramientas al mes en cada forma de hacerlo, y qué parte del ahorro se le reconoce según la pericia del equipo, o sea, qué tan bien saben usar la herramienta. Eso se captura por persona, del uno al cinco. Los ahorros publicados están calibrados para quien usa la herramienta a diario y sabe darle instrucciones. A quien nunca la ha usado solo se le reconoce treinta y cinco por ciento del ahorro, porque un modelo muy potente en manos de quien no sabe pedirle las cosas no ahorra tiempo. Eso es exactamente lo que midió el estudio de METR.</a:t>
             </a:r>
           </a:p>
         </p:txBody>
@@ -1723,7 +1723,7 @@
           <a:lstStyle/>
           <a:p>
             <a:r>
-              <a:t>Además de la encuesta, el sistema mide cosas sin preguntar. Cuánto tarda cada persona en llegar a su primera cifra. Cuántos empiezan y no terminan. Qué forma de hacerlo eligen. Y cuando un proyecto termina, se captura lo que costó de verdad. Con quince casos terminados, el sistema calcula solo las mismas métricas del artículo y da un veredicto sobre la hipótesis. Este es el panel del investigador, donde se ve todo eso.</a:t>
+              <a:t>Además de la encuesta, el sistema mide cosas sin preguntar. Cuánto tarda cada persona en llegar a su primera cifra. Cuántos empiezan y no terminan. Qué forma de hacerlo eligen. Y cuando un proyecto termina, se captura lo que costó de verdad. Con quince casos terminados, el sistema calcula solo las mismas medidas del artículo y dice si la hipótesis se cumple o no. Este es el panel del investigador, donde se ve todo eso.</a:t>
             </a:r>
           </a:p>
         </p:txBody>
@@ -2073,7 +2073,7 @@
           <a:lstStyle/>
           <a:p>
             <a:r>
-              <a:t>La pregunta de siempre en esta área es cuántas horas de programación lleva un sistema. El asunto es que la forma de hacer software está cambiando mes con mes. En 2024, seis de cada diez desarrolladores usaban inteligencia artificial. En 2025, casi ocho. En 2026, más de ocho. Y lo nuevo no es que la computadora complete una línea, sino que un agente hace la tarea completa: nueve de cada diez profesionales ya usan agentes cada semana. GitHub dice que cuarenta y uno por ciento del código nuevo se genera con inteligencia artificial. Esto ya es un mercado de diez mil millones de dólares. Para la tesis significa algo muy concreto: un modelo que asuma que las horas de programación son el centro del costo se queda corto. Por eso desde el diseño el sistema calcula con cinco formas de hacerlo, no con una sola.</a:t>
+              <a:t>La pregunta de siempre en esta área es cuántas horas de programación lleva un sistema. El asunto es que la forma de hacer software está cambiando mes con mes. En 2024, seis de cada diez desarrolladores usaban inteligencia artificial. En 2025, casi ocho. En 2026, más de ocho. Y lo nuevo no es que la computadora complete una línea, sino que un agente hace la tarea completa: nueve de cada diez profesionales ya usan agentes cada semana. GitHub dice que cuarenta y uno por ciento del código nuevo se genera con inteligencia artificial. Para la tesis significa algo muy concreto: un modelo que asuma que las horas de programación son el centro del costo se queda corto. Por eso desde el diseño el sistema calcula con cinco formas de hacerlo, no con una sola.</a:t>
             </a:r>
           </a:p>
         </p:txBody>
@@ -2143,7 +2143,7 @@
           <a:lstStyle/>
           <a:p>
             <a:r>
-              <a:t>Cierro con lo que pido. Al jurado, su opinión sobre el instrumento del piloto: las cuatro preguntas, las métricas y el umbral de quince casos. A los ayuntamientos, treinta minutos para probarlo con un proyecto real, sin cuenta y sin instalar nada. A los proveedores, cotizar un proyecto real y decirme si la cifra se acerca a lo que cobrarían. La tesis parte de una idea sencilla: los tiempos ya cambiaron, y el que cotiza como antes, o compra como antes, va a perder. Este sistema es una forma de que los dos lados de la mesa vean el mismo número, con todo lo que trae adentro, antes de firmar. Gracias.</a:t>
+              <a:t>Cierro con lo que pido. Al jurado, su opinión sobre la encuesta del piloto: las cuatro preguntas, lo que se mide sin preguntar y la regla de esperar quince casos terminados. A los ayuntamientos, treinta minutos para probarlo con un proyecto real, sin cuenta y sin instalar nada. A los proveedores, cotizar un proyecto real y decirme si la cifra se acerca a lo que cobrarían. La tesis parte de una idea sencilla: los tiempos ya cambiaron, y el que cotiza como antes, o compra como antes, va a perder. Este sistema es una forma de que los dos lados de la mesa vean el mismo número, con todo lo que trae adentro, antes de firmar. Gracias.</a:t>
             </a:r>
           </a:p>
         </p:txBody>
@@ -2353,7 +2353,7 @@
           <a:lstStyle/>
           <a:p>
             <a:r>
-              <a:t>Ahora la otra cara, porque una tesis no puede repetir el folleto de las herramientas. La inteligencia artificial no hace a todos más rápidos. El estudio más serio del año pasado midió a desarrolladores con experiencia trabajando en su propio código: tardaron diecinueve por ciento más, y ellos creían que habían sido veinte por ciento más rápidos. Otro estudio, con seiscientos millones de cambios de código, encontró que se copia mucho más y se limpia mucho menos. Casi la mitad del código generado trae una falla de seguridad. Y los cambios hechos con inteligencia artificial se aceptan mucho menos que los hechos a mano. Entonces, la ganancia depende de dos cosas: de la forma de hacerlo y de qué tan bien sabe usar la herramienta el equipo. Por eso el sistema no aplica un descuento parejo: cobra la herramienta por un lado y acredita el ahorro según la pericia por otro.</a:t>
+              <a:t>Ahora la otra cara, porque una tesis no puede repetir el folleto de las herramientas. La inteligencia artificial no hace a todos más rápidos. El estudio más serio del año pasado midió a desarrolladores con experiencia trabajando en su propio código: tardaron diecinueve por ciento más, y ellos creían que habían sido veinte por ciento más rápidos. Otro estudio, con seiscientos millones de cambios de código, encontró que se copia mucho más y se limpia mucho menos. Casi la mitad del código generado trae una falla de seguridad. Entonces, la ganancia depende de dos cosas: de la forma de hacerlo y de qué tan bien sabe usar la herramienta el equipo. Por eso el sistema no aplica un descuento parejo: cobra la herramienta por un lado y, por otro, reconoce el ahorro según qué tanto sabe usarla el equipo.</a:t>
             </a:r>
           </a:p>
         </p:txBody>
@@ -2563,7 +2563,7 @@
           <a:lstStyle/>
           <a:p>
             <a:r>
-              <a:t>Esta gráfica es del dataset JOSSE: tareas reales de proyectos de código abierto. Cada punto es una tarea. En el eje de abajo está lo que el experto estimó y en el eje vertical lo que costó de verdad. La línea diagonal sería la estimación perfecta. Fíjense en dos cosas. Una: los puntos suben junto con la línea, o sea que el experto sí sabe qué tarea es grande y cuál es chica; la correlación es de cero punto setenta y nueve. Dos: los puntos están muy regados alrededor de la línea; solo cuatro de cada diez caen cerca. El experto ordena, pero no dimensiona.</a:t>
+              <a:t>Esta gráfica es del dataset JOSSE: tareas reales de proyectos de código abierto. Cada punto es una tarea. En el eje de abajo está lo que el experto estimó y en el eje vertical lo que costó de verdad. La línea diagonal sería la estimación perfecta. Fíjense en dos cosas. Una: los puntos suben junto con la línea, o sea que el experto sí sabe qué tarea es grande y cuál es chica. Eso en estadística se llama correlación, y aquí es alta, de cero punto setenta y nueve. Dos: los puntos están muy regados alrededor de la línea; solo cuatro de cada diez caen cerca. El experto ordena, pero no dimensiona.</a:t>
             </a:r>
           </a:p>
         </p:txBody>

</xml_diff>